<commit_message>
docs: refresh final submission and remove obsolete files
Replace report and slide screenshots with the current compact view, synchronize ninety Python and eleven UI test results, and state the MCP data boundary. Preserve the measured sixty-six request comparison. Remove obsolete stage notes, superseded assets and unused report scripts while retaining reproduction dependencies.
</commit_message>
<xml_diff>
--- a/output/AI_Agent_개선_최종발표.pptx
+++ b/output/AI_Agent_개선_최종발표.pptx
@@ -2,21 +2,21 @@
 <file path=ppt/presentation.xml><?xml version="1.0" encoding="utf-8"?>
 <p:presentation xmlns:p="http://schemas.openxmlformats.org/presentationml/2006/main">
   <p:sldMasterIdLst>
-    <p:sldMasterId xmlns:r="http://schemas.openxmlformats.org/officeDocument/2006/relationships" id="2147483648" r:id="R77d2776eb5a14ad1"/>
+    <p:sldMasterId xmlns:r="http://schemas.openxmlformats.org/officeDocument/2006/relationships" id="2147483648" r:id="Rd3f045841ec04fa7"/>
   </p:sldMasterIdLst>
   <p:notesMasterIdLst>
-    <p:notesMasterId xmlns:r="http://schemas.openxmlformats.org/officeDocument/2006/relationships" r:id="R1fdef60634d2402d"/>
+    <p:notesMasterId xmlns:r="http://schemas.openxmlformats.org/officeDocument/2006/relationships" r:id="R234c6d2e8cdb48ae"/>
   </p:notesMasterIdLst>
   <p:sldIdLst>
-    <p:sldId xmlns:r="http://schemas.openxmlformats.org/officeDocument/2006/relationships" id="256" r:id="R0dffc35f83ea4071"/>
-    <p:sldId xmlns:r="http://schemas.openxmlformats.org/officeDocument/2006/relationships" id="257" r:id="R663c6a1578da448f"/>
-    <p:sldId xmlns:r="http://schemas.openxmlformats.org/officeDocument/2006/relationships" id="258" r:id="R4f623981b7314d88"/>
-    <p:sldId xmlns:r="http://schemas.openxmlformats.org/officeDocument/2006/relationships" id="259" r:id="R1a945ace9b644406"/>
-    <p:sldId xmlns:r="http://schemas.openxmlformats.org/officeDocument/2006/relationships" id="260" r:id="Radf5580c18724685"/>
-    <p:sldId xmlns:r="http://schemas.openxmlformats.org/officeDocument/2006/relationships" id="261" r:id="Rde1db7b87883492c"/>
-    <p:sldId xmlns:r="http://schemas.openxmlformats.org/officeDocument/2006/relationships" id="262" r:id="R874e62326aaf4a65"/>
-    <p:sldId xmlns:r="http://schemas.openxmlformats.org/officeDocument/2006/relationships" id="263" r:id="Rb28d15e3eb5a4588"/>
-    <p:sldId xmlns:r="http://schemas.openxmlformats.org/officeDocument/2006/relationships" id="264" r:id="R952695533e6a41b4"/>
+    <p:sldId xmlns:r="http://schemas.openxmlformats.org/officeDocument/2006/relationships" id="256" r:id="Rb6f584fc85a74181"/>
+    <p:sldId xmlns:r="http://schemas.openxmlformats.org/officeDocument/2006/relationships" id="257" r:id="Ra7280c202a3441a4"/>
+    <p:sldId xmlns:r="http://schemas.openxmlformats.org/officeDocument/2006/relationships" id="258" r:id="R175ebd26dbdc4118"/>
+    <p:sldId xmlns:r="http://schemas.openxmlformats.org/officeDocument/2006/relationships" id="259" r:id="Re381094b14d34fa0"/>
+    <p:sldId xmlns:r="http://schemas.openxmlformats.org/officeDocument/2006/relationships" id="260" r:id="Rbe3eea440a794fdc"/>
+    <p:sldId xmlns:r="http://schemas.openxmlformats.org/officeDocument/2006/relationships" id="261" r:id="Rcda5fa8efab64dc0"/>
+    <p:sldId xmlns:r="http://schemas.openxmlformats.org/officeDocument/2006/relationships" id="262" r:id="R9ad18d16cf51412f"/>
+    <p:sldId xmlns:r="http://schemas.openxmlformats.org/officeDocument/2006/relationships" id="263" r:id="R99b0e73361a74d29"/>
+    <p:sldId xmlns:r="http://schemas.openxmlformats.org/officeDocument/2006/relationships" id="264" r:id="R3b4168cf6c524ec8"/>
   </p:sldIdLst>
   <p:sldSz cx="12192000" cy="6858000"/>
   <p:notesSz cx="6858000" cy="9144000"/>
@@ -470,7 +470,7 @@
           </a:p>
           <a:p xmlns:a="http://schemas.openxmlformats.org/drawingml/2006/main">
             <a:r>
-              <a:t>doc/report.md 1절 / 원본 0d8405e·최종 제품 69d58eb</a:t>
+              <a:t>원본 0d8405e · 실측 제품 69d58eb · 최신 표시 f2e26e1 / doc/report.md</a:t>
             </a:r>
           </a:p>
         </p:txBody>
@@ -545,7 +545,7 @@
           </a:p>
           <a:p xmlns:a="http://schemas.openxmlformats.org/drawingml/2006/main">
             <a:r>
-              <a:t>기존에도 MCP 조회와 런북 기반 작성, 복수 서비스 계획과 대화 저장이 있었습니다. 저는 전체 요청 대상과 실제 조회값을 대조하는 검사를 보완했습니다. 런북은 첫 키워드 유형 선택에서 질문과 서비스별 알림을 활용하는 RAG로 바꿨습니다. Writer는 절차 ID를 고르고 코드가 사실과 조건을 조립하도록 했으며, 복잡한 요청에 별도 Reviewer를 추가했습니다. 운영 후속 질문의 대상과 늦은 화면 이벤트도 구분했습니다.</a:t>
+              <a:t>기존에도 MCP 조회와 런북 기반 작성, 복수 서비스 계획과 대화 저장이 있었습니다. 저는 요청 대상과 실제 조회값을 대조하고, 런북을 질문과 서비스별 알림으로 검색하도록 바꿨습니다. Writer는 절차 ID를 고르고 코드가 사실과 조건을 조립하며, 복잡한 요청에는 Reviewer를 추가했습니다. 최신 화면은 핵심을 먼저 표시하고 전체 근거를 접습니다. 최신 검사는 Python 아흔 개와 화면 열한 개가 통과했습니다.</a:t>
             </a:r>
           </a:p>
           <a:p xmlns:a="http://schemas.openxmlformats.org/drawingml/2006/main">
@@ -560,7 +560,7 @@
           </a:p>
           <a:p xmlns:a="http://schemas.openxmlformats.org/drawingml/2006/main">
             <a:r>
-              <a:t>doc/original_final_feature_audit.md / 19개 기능 코드 대조</a:t>
+              <a:t>doc/report.md / 최신 제출 소스 Python 90개·화면 11개 / 통제 테스트와 실제 API 구분</a:t>
             </a:r>
           </a:p>
         </p:txBody>
@@ -635,7 +635,7 @@
           </a:p>
           <a:p xmlns:a="http://schemas.openxmlformats.org/drawingml/2006/main">
             <a:r>
-              <a:t>화면은 같은 메모리 질문을 최종본에서 실제 실행한 결과입니다. 원본은 현재 메모리 89퍼센트에도 즉시 재시작을 권고했습니다. 최종본은 현재값, 원인 가설, 미확보 자료와 런북 출처를 나눕니다. 실제 조치는 실행하지 않습니다. 이 캡처 시연은 다음 통계와 별도로 기록했습니다.</a:t>
+              <a:t>같은 메모리 질문과 고정 샘플을 최신 화면에 입력한 결과입니다. 현재 메모리 89퍼센트와 추가 점검을 먼저 보여주고, 원문과 긴 근거는 펼쳐 보도록 바꿨습니다. 실제 조치는 실행하지 않습니다. 요약용 모델 호출이나 검수 기준 변경도 없습니다. 이 화면 시연은 다음 예순여섯 건 실측과 분리했습니다.</a:t>
             </a:r>
           </a:p>
           <a:p xmlns:a="http://schemas.openxmlformats.org/drawingml/2006/main">
@@ -650,7 +650,7 @@
           </a:p>
           <a:p xmlns:a="http://schemas.openxmlformats.org/drawingml/2006/main">
             <a:r>
-              <a:t>doc/assets/before_comparison.jpg·after_comparison.jpg / 별도 실제 실행 캡처 / 수업용 고정 샘플</a:t>
+              <a:t>doc/assets/current_answer.png / 실제 OpenAI·고정 수업 샘플 89% / 별도 화면 시연 / API 원문·검수 보존</a:t>
             </a:r>
           </a:p>
         </p:txBody>
@@ -905,7 +905,7 @@
           </a:p>
           <a:p xmlns:a="http://schemas.openxmlformats.org/drawingml/2006/main">
             <a:r>
-              <a:t>MCP는 기존 통로를 재사용했습니다. 새로 연결한 부분은 retrieve_runbooks_node입니다. 먼저 런북 Resource를 제공하는 서버와 주소 양식을 찾습니다. RAG가 고른 key를 그 주소에 넣고 read_resource로 원문을 읽습니다. 이어 등록된 ID인지, 읽은 원문과 카탈로그의 해시가 같은지 확인합니다. 모니터링은 Tool, 매뉴얼은 Resource라는 역할 차이입니다. 해시는 내용 일치만 확인하며 최신성이나 정답을 보장하지는 않습니다.</a:t>
+              <a:t>MCP는 기존 통로를 재사용했습니다. retrieve_runbooks_node에서 런북 Resource의 서버와 주소 양식을 찾고, RAG가 고른 key로 원문을 읽어 해시를 대조합니다. 모니터링은 Tool, 매뉴얼은 Resource입니다. 현재 Tool은 상태와 CPU, 메모리, 알림을 제공하며 p95나 커넥션 풀의 현재값을 직접 조회하지는 않습니다. 런북의 추가 점검은 별도 자료로 확인해야 합니다.</a:t>
             </a:r>
           </a:p>
           <a:p xmlns:a="http://schemas.openxmlformats.org/drawingml/2006/main">
@@ -920,7 +920,7 @@
           </a:p>
           <a:p xmlns:a="http://schemas.openxmlformats.org/drawingml/2006/main">
             <a:r>
-              <a:t>agent/graph.py retrieve_runbooks_node() / agent/mcp_client.py 원본 동일 / 호출부 발췌 줄바꿈 정리</a:t>
+              <a:t>agent/graph.py retrieve_runbooks_node() / mcp_server.py SystemStatus / 기존 MCP 클라이언트 유지</a:t>
             </a:r>
           </a:p>
         </p:txBody>
@@ -1175,7 +1175,7 @@
           </a:p>
           <a:p xmlns:a="http://schemas.openxmlformats.org/drawingml/2006/main">
             <a:r>
-              <a:t>검수 강화로 입력 토큰이 늘었고, 샘플에는 시계열과 배포 이력이 없어 근본 원인을 확정할 수 없습니다. 이후에는 미지원 서비스의 대체 정책과 검색 입력 예산을 개선하고, 사람의 정답 채점으로 품질을 확인하고 싶습니다. 감사합니다.</a:t>
+              <a:t>입력 토큰이 늘었고, 현재 p95와 커넥션 풀, 시계열과 로그를 직접 조회하지 않으므로 원인을 확정할 수 없습니다. 이후에는 미지원 서비스의 대체 정책과 검색 입력 예산을 개선하고, 사람이 정답을 채점해 품질을 확인하고 싶습니다. 감사합니다.</a:t>
             </a:r>
           </a:p>
           <a:p xmlns:a="http://schemas.openxmlformats.org/drawingml/2006/main">
@@ -3633,12 +3633,12 @@
   </p:cSld>
   <p:clrMap bg1="lt1" tx1="dk1" bg2="lt2" tx2="dk2" accent1="accent1" accent2="accent2" accent3="accent3" accent4="accent4" accent5="accent5" accent6="accent6" hlink="hlink" folHlink="folHlink"/>
   <p:sldLayoutIdLst>
-    <p:sldLayoutId xmlns:r="http://schemas.openxmlformats.org/officeDocument/2006/relationships" id="2147483649" r:id="R1d4ac03ad04547aa"/>
-    <p:sldLayoutId xmlns:r="http://schemas.openxmlformats.org/officeDocument/2006/relationships" id="2147483650" r:id="Rba1dfbf2876748d6"/>
-    <p:sldLayoutId xmlns:r="http://schemas.openxmlformats.org/officeDocument/2006/relationships" id="2147483651" r:id="R96e9e051a49143a7"/>
-    <p:sldLayoutId xmlns:r="http://schemas.openxmlformats.org/officeDocument/2006/relationships" id="2147483652" r:id="Rb45bb788580c4e4d"/>
-    <p:sldLayoutId xmlns:r="http://schemas.openxmlformats.org/officeDocument/2006/relationships" id="2147483653" r:id="R34b158f7aa354277"/>
-    <p:sldLayoutId xmlns:r="http://schemas.openxmlformats.org/officeDocument/2006/relationships" id="2147483654" r:id="R78a87e0e9a7549e7"/>
+    <p:sldLayoutId xmlns:r="http://schemas.openxmlformats.org/officeDocument/2006/relationships" id="2147483649" r:id="R625a77fb925541bc"/>
+    <p:sldLayoutId xmlns:r="http://schemas.openxmlformats.org/officeDocument/2006/relationships" id="2147483650" r:id="Ra705748f3e814371"/>
+    <p:sldLayoutId xmlns:r="http://schemas.openxmlformats.org/officeDocument/2006/relationships" id="2147483651" r:id="R290ab6b056ea4bb7"/>
+    <p:sldLayoutId xmlns:r="http://schemas.openxmlformats.org/officeDocument/2006/relationships" id="2147483652" r:id="R2598f4fb3eca4faf"/>
+    <p:sldLayoutId xmlns:r="http://schemas.openxmlformats.org/officeDocument/2006/relationships" id="2147483653" r:id="Re99043c2c8a94f7c"/>
+    <p:sldLayoutId xmlns:r="http://schemas.openxmlformats.org/officeDocument/2006/relationships" id="2147483654" r:id="Ra4b0694f8abf4175"/>
   </p:sldLayoutIdLst>
   <p:txStyles>
     <p:titleStyle>
@@ -4737,7 +4737,7 @@
                 <a:ea typeface="Apple SD Gothic Neo"/>
                 <a:cs typeface="Apple SD Gothic Neo"/>
               </a:rPr>
-              <a:t>수업용 샘플 / 제품 소스 69d58eb / 2026.10.21</a:t>
+              <a:t>수업용 샘플 / 실측 69d58eb · 최신 화면 f2e26e1 / 2026.10.21</a:t>
             </a:r>
           </a:p>
         </p:txBody>
@@ -6184,7 +6184,7 @@
                 <a:ea typeface="Apple SD Gothic Neo"/>
                 <a:cs typeface="Apple SD Gothic Neo"/>
               </a:rPr>
-              <a:t>기존 기반 유지: MCP·LangGraph·DI·LangSmith·SQLite·기본 역할 분리</a:t>
+              <a:t>기존 기반 유지: MCP·LangGraph·DI·LangSmith·SQLite / 최신 검사 Python 90개·화면 11개</a:t>
             </a:r>
           </a:p>
         </p:txBody>
@@ -8433,7 +8433,7 @@
           <p:cNvPr id="13" name="">
             <a:extLst xmlns:a="http://schemas.openxmlformats.org/drawingml/2006/main">
               <a:ext uri="{FF2B5EF4-FFF2-40B4-BE49-F238E27FC236}">
-                <a16:creationId xmlns:a16="http://schemas.microsoft.com/office/drawing/2014/main" id="{AD303114-26E0-44A9-9E30-3C8F8DD85F9B}"/>
+                <a16:creationId xmlns:a16="http://schemas.microsoft.com/office/drawing/2014/main" id="{C85D1E9F-12F6-45B9-AD48-64A0B9188466}"/>
               </a:ext>
             </a:extLst>
           </p:cNvPr>
@@ -8443,7 +8443,7 @@
           <p:nvPr/>
         </p:nvPicPr>
         <p:blipFill>
-          <a:blip xmlns:r="http://schemas.openxmlformats.org/officeDocument/2006/relationships" xmlns:a="http://schemas.openxmlformats.org/drawingml/2006/main" r:embed="R0d9d50d699ad4f28"/>
+          <a:blip xmlns:r="http://schemas.openxmlformats.org/officeDocument/2006/relationships" xmlns:a="http://schemas.openxmlformats.org/drawingml/2006/main" r:embed="R618895791d7340e3"/>
           <a:stretch xmlns:a="http://schemas.openxmlformats.org/drawingml/2006/main"/>
         </p:blipFill>
         <p:spPr>
@@ -8494,6 +8494,7 @@
               </a:defRPr>
             </a:defPPr>
             <a:lvl1pPr>
+              <a:buNone/>
               <a:defRPr sz="1950" b="1">
                 <a:solidFill>
                   <a:srgbClr val="0D766F"/>
@@ -8501,6 +8502,7 @@
               </a:defRPr>
             </a:lvl1pPr>
             <a:lvl2pPr>
+              <a:buNone/>
               <a:defRPr sz="1950" b="1">
                 <a:solidFill>
                   <a:srgbClr val="0D766F"/>
@@ -8508,6 +8510,7 @@
               </a:defRPr>
             </a:lvl2pPr>
             <a:lvl3pPr>
+              <a:buNone/>
               <a:defRPr sz="1950" b="1">
                 <a:solidFill>
                   <a:srgbClr val="0D766F"/>
@@ -8515,6 +8518,7 @@
               </a:defRPr>
             </a:lvl3pPr>
             <a:lvl4pPr>
+              <a:buNone/>
               <a:defRPr sz="1950" b="1">
                 <a:solidFill>
                   <a:srgbClr val="0D766F"/>
@@ -8522,6 +8526,7 @@
               </a:defRPr>
             </a:lvl4pPr>
             <a:lvl5pPr>
+              <a:buNone/>
               <a:defRPr sz="1950" b="1">
                 <a:solidFill>
                   <a:srgbClr val="0D766F"/>
@@ -8529,6 +8534,7 @@
               </a:defRPr>
             </a:lvl5pPr>
             <a:lvl6pPr>
+              <a:buNone/>
               <a:defRPr sz="1950" b="1">
                 <a:solidFill>
                   <a:srgbClr val="0D766F"/>
@@ -8536,6 +8542,7 @@
               </a:defRPr>
             </a:lvl6pPr>
             <a:lvl7pPr>
+              <a:buNone/>
               <a:defRPr sz="1950" b="1">
                 <a:solidFill>
                   <a:srgbClr val="0D766F"/>
@@ -8543,6 +8550,7 @@
               </a:defRPr>
             </a:lvl7pPr>
             <a:lvl8pPr>
+              <a:buNone/>
               <a:defRPr sz="1950" b="1">
                 <a:solidFill>
                   <a:srgbClr val="0D766F"/>
@@ -8550,6 +8558,7 @@
               </a:defRPr>
             </a:lvl8pPr>
             <a:lvl9pPr>
+              <a:buNone/>
               <a:defRPr sz="1950" b="1">
                 <a:solidFill>
                   <a:srgbClr val="0D766F"/>
@@ -8559,6 +8568,7 @@
           </a:lstStyle>
           <a:p xmlns:a="http://schemas.openxmlformats.org/drawingml/2006/main">
             <a:pPr>
+              <a:buNone/>
               <a:defRPr sz="1950" b="1">
                 <a:solidFill>
                   <a:srgbClr val="0D766F"/>
@@ -8571,7 +8581,7 @@
                   <a:srgbClr val="0D766F"/>
                 </a:solidFill>
               </a:rPr>
-              <a:t>메모리 질문의 실제 출력</a:t>
+              <a:t>최신 답변 화면</a:t>
             </a:r>
           </a:p>
         </p:txBody>
@@ -8614,6 +8624,7 @@
               </a:defRPr>
             </a:defPPr>
             <a:lvl1pPr>
+              <a:buNone/>
               <a:defRPr sz="1800" b="0">
                 <a:solidFill>
                   <a:srgbClr val="192E50"/>
@@ -8621,6 +8632,7 @@
               </a:defRPr>
             </a:lvl1pPr>
             <a:lvl2pPr>
+              <a:buNone/>
               <a:defRPr sz="1800" b="0">
                 <a:solidFill>
                   <a:srgbClr val="192E50"/>
@@ -8628,6 +8640,7 @@
               </a:defRPr>
             </a:lvl2pPr>
             <a:lvl3pPr>
+              <a:buNone/>
               <a:defRPr sz="1800" b="0">
                 <a:solidFill>
                   <a:srgbClr val="192E50"/>
@@ -8635,6 +8648,7 @@
               </a:defRPr>
             </a:lvl3pPr>
             <a:lvl4pPr>
+              <a:buNone/>
               <a:defRPr sz="1800" b="0">
                 <a:solidFill>
                   <a:srgbClr val="192E50"/>
@@ -8642,6 +8656,7 @@
               </a:defRPr>
             </a:lvl4pPr>
             <a:lvl5pPr>
+              <a:buNone/>
               <a:defRPr sz="1800" b="0">
                 <a:solidFill>
                   <a:srgbClr val="192E50"/>
@@ -8649,6 +8664,7 @@
               </a:defRPr>
             </a:lvl5pPr>
             <a:lvl6pPr>
+              <a:buNone/>
               <a:defRPr sz="1800" b="0">
                 <a:solidFill>
                   <a:srgbClr val="192E50"/>
@@ -8656,6 +8672,7 @@
               </a:defRPr>
             </a:lvl6pPr>
             <a:lvl7pPr>
+              <a:buNone/>
               <a:defRPr sz="1800" b="0">
                 <a:solidFill>
                   <a:srgbClr val="192E50"/>
@@ -8663,6 +8680,7 @@
               </a:defRPr>
             </a:lvl7pPr>
             <a:lvl8pPr>
+              <a:buNone/>
               <a:defRPr sz="1800" b="0">
                 <a:solidFill>
                   <a:srgbClr val="192E50"/>
@@ -8670,6 +8688,7 @@
               </a:defRPr>
             </a:lvl8pPr>
             <a:lvl9pPr>
+              <a:buNone/>
               <a:defRPr sz="1800" b="0">
                 <a:solidFill>
                   <a:srgbClr val="192E50"/>
@@ -8679,6 +8698,7 @@
           </a:lstStyle>
           <a:p xmlns:a="http://schemas.openxmlformats.org/drawingml/2006/main">
             <a:pPr>
+              <a:buNone/>
               <a:defRPr sz="1800" b="0">
                 <a:solidFill>
                   <a:srgbClr val="192E50"/>
@@ -8695,12 +8715,46 @@
             </a:r>
           </a:p>
           <a:p xmlns:a="http://schemas.openxmlformats.org/drawingml/2006/main">
+            <a:pPr>
+              <a:buNone/>
+              <a:defRPr sz="1800" b="0">
+                <a:solidFill>
+                  <a:srgbClr val="192E50"/>
+                </a:solidFill>
+              </a:defRPr>
+            </a:pPr>
+          </a:p>
+          <a:p xmlns:a="http://schemas.openxmlformats.org/drawingml/2006/main">
+            <a:pPr>
+              <a:buNone/>
+              <a:defRPr sz="1800" b="0">
+                <a:solidFill>
+                  <a:srgbClr val="192E50"/>
+                </a:solidFill>
+              </a:defRPr>
+            </a:pPr>
             <a:r>
-              <a:t/>
+              <a:rPr sz="1800" b="0">
+                <a:solidFill>
+                  <a:srgbClr val="192E50"/>
+                </a:solidFill>
+              </a:rPr>
+              <a:t>추가 점검을 먼저 표시</a:t>
             </a:r>
           </a:p>
           <a:p xmlns:a="http://schemas.openxmlformats.org/drawingml/2006/main">
             <a:pPr>
+              <a:buNone/>
+              <a:defRPr sz="1800" b="0">
+                <a:solidFill>
+                  <a:srgbClr val="192E50"/>
+                </a:solidFill>
+              </a:defRPr>
+            </a:pPr>
+          </a:p>
+          <a:p xmlns:a="http://schemas.openxmlformats.org/drawingml/2006/main">
+            <a:pPr>
+              <a:buNone/>
               <a:defRPr sz="1800" b="0">
                 <a:solidFill>
                   <a:srgbClr val="192E50"/>
@@ -8713,16 +8767,22 @@
                   <a:srgbClr val="192E50"/>
                 </a:solidFill>
               </a:rPr>
-              <a:t>원인 후보는 가설로 표시</a:t>
-            </a:r>
-          </a:p>
-          <a:p xmlns:a="http://schemas.openxmlformats.org/drawingml/2006/main">
-            <a:r>
-              <a:t/>
+              <a:t>원문·근거는 펼쳐 보기</a:t>
             </a:r>
           </a:p>
           <a:p xmlns:a="http://schemas.openxmlformats.org/drawingml/2006/main">
             <a:pPr>
+              <a:buNone/>
+              <a:defRPr sz="1800" b="0">
+                <a:solidFill>
+                  <a:srgbClr val="192E50"/>
+                </a:solidFill>
+              </a:defRPr>
+            </a:pPr>
+          </a:p>
+          <a:p xmlns:a="http://schemas.openxmlformats.org/drawingml/2006/main">
+            <a:pPr>
+              <a:buNone/>
               <a:defRPr sz="1800" b="0">
                 <a:solidFill>
                   <a:srgbClr val="192E50"/>
@@ -8735,29 +8795,7 @@
                   <a:srgbClr val="192E50"/>
                 </a:solidFill>
               </a:rPr>
-              <a:t>시계열·배포 이력 미확보</a:t>
-            </a:r>
-          </a:p>
-          <a:p xmlns:a="http://schemas.openxmlformats.org/drawingml/2006/main">
-            <a:r>
-              <a:t/>
-            </a:r>
-          </a:p>
-          <a:p xmlns:a="http://schemas.openxmlformats.org/drawingml/2006/main">
-            <a:pPr>
-              <a:defRPr sz="1800" b="0">
-                <a:solidFill>
-                  <a:srgbClr val="192E50"/>
-                </a:solidFill>
-              </a:defRPr>
-            </a:pPr>
-            <a:r>
-              <a:rPr sz="1800" b="0">
-                <a:solidFill>
-                  <a:srgbClr val="192E50"/>
-                </a:solidFill>
-              </a:rPr>
-              <a:t>런북 원문 출처 연결</a:t>
+              <a:t>실제 조치는 미실행</a:t>
             </a:r>
           </a:p>
         </p:txBody>
@@ -8800,6 +8838,7 @@
               </a:defRPr>
             </a:defPPr>
             <a:lvl1pPr>
+              <a:buNone/>
               <a:defRPr sz="1350" b="0">
                 <a:solidFill>
                   <a:srgbClr val="566B88"/>
@@ -8807,6 +8846,7 @@
               </a:defRPr>
             </a:lvl1pPr>
             <a:lvl2pPr>
+              <a:buNone/>
               <a:defRPr sz="1350" b="0">
                 <a:solidFill>
                   <a:srgbClr val="566B88"/>
@@ -8814,6 +8854,7 @@
               </a:defRPr>
             </a:lvl2pPr>
             <a:lvl3pPr>
+              <a:buNone/>
               <a:defRPr sz="1350" b="0">
                 <a:solidFill>
                   <a:srgbClr val="566B88"/>
@@ -8821,6 +8862,7 @@
               </a:defRPr>
             </a:lvl3pPr>
             <a:lvl4pPr>
+              <a:buNone/>
               <a:defRPr sz="1350" b="0">
                 <a:solidFill>
                   <a:srgbClr val="566B88"/>
@@ -8828,6 +8870,7 @@
               </a:defRPr>
             </a:lvl4pPr>
             <a:lvl5pPr>
+              <a:buNone/>
               <a:defRPr sz="1350" b="0">
                 <a:solidFill>
                   <a:srgbClr val="566B88"/>
@@ -8835,6 +8878,7 @@
               </a:defRPr>
             </a:lvl5pPr>
             <a:lvl6pPr>
+              <a:buNone/>
               <a:defRPr sz="1350" b="0">
                 <a:solidFill>
                   <a:srgbClr val="566B88"/>
@@ -8842,6 +8886,7 @@
               </a:defRPr>
             </a:lvl6pPr>
             <a:lvl7pPr>
+              <a:buNone/>
               <a:defRPr sz="1350" b="0">
                 <a:solidFill>
                   <a:srgbClr val="566B88"/>
@@ -8849,6 +8894,7 @@
               </a:defRPr>
             </a:lvl7pPr>
             <a:lvl8pPr>
+              <a:buNone/>
               <a:defRPr sz="1350" b="0">
                 <a:solidFill>
                   <a:srgbClr val="566B88"/>
@@ -8856,6 +8902,7 @@
               </a:defRPr>
             </a:lvl8pPr>
             <a:lvl9pPr>
+              <a:buNone/>
               <a:defRPr sz="1350" b="0">
                 <a:solidFill>
                   <a:srgbClr val="566B88"/>
@@ -8865,6 +8912,7 @@
           </a:lstStyle>
           <a:p xmlns:a="http://schemas.openxmlformats.org/drawingml/2006/main">
             <a:pPr>
+              <a:buNone/>
               <a:defRPr sz="1350" b="0">
                 <a:solidFill>
                   <a:srgbClr val="566B88"/>
@@ -8877,7 +8925,7 @@
                   <a:srgbClr val="566B88"/>
                 </a:solidFill>
               </a:rPr>
-              <a:t>동일 질문의 별도 화면 시연입니다. 66건 통계와 분리했습니다.</a:t>
+              <a:t>같은 고정 샘플의 최신 화면입니다. 원문·검수는 유지하며 66건 실측과 분리했습니다.</a:t>
             </a:r>
           </a:p>
         </p:txBody>
@@ -9640,7 +9688,7 @@
           <p:cNvPr id="7" name="">
             <a:extLst xmlns:a="http://schemas.openxmlformats.org/drawingml/2006/main">
               <a:ext uri="{FF2B5EF4-FFF2-40B4-BE49-F238E27FC236}">
-                <a16:creationId xmlns:a16="http://schemas.microsoft.com/office/drawing/2014/main" id="{38F5E370-6706-42A5-B087-B2D0285C08E6}"/>
+                <a16:creationId xmlns:a16="http://schemas.microsoft.com/office/drawing/2014/main" id="{AC26BF7E-E247-4B78-8F2F-A79410848048}"/>
               </a:ext>
             </a:extLst>
           </p:cNvPr>
@@ -15162,6 +15210,7 @@
               </a:defRPr>
             </a:defPPr>
             <a:lvl1pPr>
+              <a:buNone/>
               <a:defRPr sz="1800" b="1">
                 <a:solidFill>
                   <a:srgbClr val="0D766F"/>
@@ -15169,6 +15218,7 @@
               </a:defRPr>
             </a:lvl1pPr>
             <a:lvl2pPr>
+              <a:buNone/>
               <a:defRPr sz="1800" b="1">
                 <a:solidFill>
                   <a:srgbClr val="0D766F"/>
@@ -15176,6 +15226,7 @@
               </a:defRPr>
             </a:lvl2pPr>
             <a:lvl3pPr>
+              <a:buNone/>
               <a:defRPr sz="1800" b="1">
                 <a:solidFill>
                   <a:srgbClr val="0D766F"/>
@@ -15183,6 +15234,7 @@
               </a:defRPr>
             </a:lvl3pPr>
             <a:lvl4pPr>
+              <a:buNone/>
               <a:defRPr sz="1800" b="1">
                 <a:solidFill>
                   <a:srgbClr val="0D766F"/>
@@ -15190,6 +15242,7 @@
               </a:defRPr>
             </a:lvl4pPr>
             <a:lvl5pPr>
+              <a:buNone/>
               <a:defRPr sz="1800" b="1">
                 <a:solidFill>
                   <a:srgbClr val="0D766F"/>
@@ -15197,6 +15250,7 @@
               </a:defRPr>
             </a:lvl5pPr>
             <a:lvl6pPr>
+              <a:buNone/>
               <a:defRPr sz="1800" b="1">
                 <a:solidFill>
                   <a:srgbClr val="0D766F"/>
@@ -15204,6 +15258,7 @@
               </a:defRPr>
             </a:lvl6pPr>
             <a:lvl7pPr>
+              <a:buNone/>
               <a:defRPr sz="1800" b="1">
                 <a:solidFill>
                   <a:srgbClr val="0D766F"/>
@@ -15211,6 +15266,7 @@
               </a:defRPr>
             </a:lvl7pPr>
             <a:lvl8pPr>
+              <a:buNone/>
               <a:defRPr sz="1800" b="1">
                 <a:solidFill>
                   <a:srgbClr val="0D766F"/>
@@ -15218,6 +15274,7 @@
               </a:defRPr>
             </a:lvl8pPr>
             <a:lvl9pPr>
+              <a:buNone/>
               <a:defRPr sz="1800" b="1">
                 <a:solidFill>
                   <a:srgbClr val="0D766F"/>
@@ -15227,6 +15284,7 @@
           </a:lstStyle>
           <a:p xmlns:a="http://schemas.openxmlformats.org/drawingml/2006/main">
             <a:pPr>
+              <a:buNone/>
               <a:defRPr sz="1800" b="1">
                 <a:solidFill>
                   <a:srgbClr val="0D766F"/>
@@ -15282,6 +15340,7 @@
               </a:defRPr>
             </a:defPPr>
             <a:lvl1pPr>
+              <a:buNone/>
               <a:defRPr sz="1500" b="0">
                 <a:solidFill>
                   <a:srgbClr val="192E50"/>
@@ -15289,6 +15348,7 @@
               </a:defRPr>
             </a:lvl1pPr>
             <a:lvl2pPr>
+              <a:buNone/>
               <a:defRPr sz="1500" b="0">
                 <a:solidFill>
                   <a:srgbClr val="192E50"/>
@@ -15296,6 +15356,7 @@
               </a:defRPr>
             </a:lvl2pPr>
             <a:lvl3pPr>
+              <a:buNone/>
               <a:defRPr sz="1500" b="0">
                 <a:solidFill>
                   <a:srgbClr val="192E50"/>
@@ -15303,6 +15364,7 @@
               </a:defRPr>
             </a:lvl3pPr>
             <a:lvl4pPr>
+              <a:buNone/>
               <a:defRPr sz="1500" b="0">
                 <a:solidFill>
                   <a:srgbClr val="192E50"/>
@@ -15310,6 +15372,7 @@
               </a:defRPr>
             </a:lvl4pPr>
             <a:lvl5pPr>
+              <a:buNone/>
               <a:defRPr sz="1500" b="0">
                 <a:solidFill>
                   <a:srgbClr val="192E50"/>
@@ -15317,6 +15380,7 @@
               </a:defRPr>
             </a:lvl5pPr>
             <a:lvl6pPr>
+              <a:buNone/>
               <a:defRPr sz="1500" b="0">
                 <a:solidFill>
                   <a:srgbClr val="192E50"/>
@@ -15324,6 +15388,7 @@
               </a:defRPr>
             </a:lvl6pPr>
             <a:lvl7pPr>
+              <a:buNone/>
               <a:defRPr sz="1500" b="0">
                 <a:solidFill>
                   <a:srgbClr val="192E50"/>
@@ -15331,6 +15396,7 @@
               </a:defRPr>
             </a:lvl7pPr>
             <a:lvl8pPr>
+              <a:buNone/>
               <a:defRPr sz="1500" b="0">
                 <a:solidFill>
                   <a:srgbClr val="192E50"/>
@@ -15338,6 +15404,7 @@
               </a:defRPr>
             </a:lvl8pPr>
             <a:lvl9pPr>
+              <a:buNone/>
               <a:defRPr sz="1500" b="0">
                 <a:solidFill>
                   <a:srgbClr val="192E50"/>
@@ -15347,6 +15414,7 @@
           </a:lstStyle>
           <a:p xmlns:a="http://schemas.openxmlformats.org/drawingml/2006/main">
             <a:pPr>
+              <a:buNone/>
               <a:defRPr sz="1500" b="0">
                 <a:solidFill>
                   <a:srgbClr val="192E50"/>
@@ -15364,6 +15432,7 @@
           </a:p>
           <a:p xmlns:a="http://schemas.openxmlformats.org/drawingml/2006/main">
             <a:pPr>
+              <a:buNone/>
               <a:defRPr sz="1500" b="0">
                 <a:solidFill>
                   <a:srgbClr val="192E50"/>
@@ -15381,6 +15450,7 @@
           </a:p>
           <a:p xmlns:a="http://schemas.openxmlformats.org/drawingml/2006/main">
             <a:pPr>
+              <a:buNone/>
               <a:defRPr sz="1500" b="0">
                 <a:solidFill>
                   <a:srgbClr val="192E50"/>
@@ -15398,6 +15468,7 @@
           </a:p>
           <a:p xmlns:a="http://schemas.openxmlformats.org/drawingml/2006/main">
             <a:pPr>
+              <a:buNone/>
               <a:defRPr sz="1500" b="0">
                 <a:solidFill>
                   <a:srgbClr val="192E50"/>
@@ -15415,6 +15486,7 @@
           </a:p>
           <a:p xmlns:a="http://schemas.openxmlformats.org/drawingml/2006/main">
             <a:pPr>
+              <a:buNone/>
               <a:defRPr sz="1500" b="0">
                 <a:solidFill>
                   <a:srgbClr val="192E50"/>
@@ -15432,6 +15504,7 @@
           </a:p>
           <a:p xmlns:a="http://schemas.openxmlformats.org/drawingml/2006/main">
             <a:pPr>
+              <a:buNone/>
               <a:defRPr sz="1500" b="0">
                 <a:solidFill>
                   <a:srgbClr val="192E50"/>
@@ -15487,6 +15560,7 @@
               </a:defRPr>
             </a:defPPr>
             <a:lvl1pPr>
+              <a:buNone/>
               <a:defRPr sz="1950" b="1">
                 <a:solidFill>
                   <a:srgbClr val="0D766F"/>
@@ -15494,6 +15568,7 @@
               </a:defRPr>
             </a:lvl1pPr>
             <a:lvl2pPr>
+              <a:buNone/>
               <a:defRPr sz="1950" b="1">
                 <a:solidFill>
                   <a:srgbClr val="0D766F"/>
@@ -15501,6 +15576,7 @@
               </a:defRPr>
             </a:lvl2pPr>
             <a:lvl3pPr>
+              <a:buNone/>
               <a:defRPr sz="1950" b="1">
                 <a:solidFill>
                   <a:srgbClr val="0D766F"/>
@@ -15508,6 +15584,7 @@
               </a:defRPr>
             </a:lvl3pPr>
             <a:lvl4pPr>
+              <a:buNone/>
               <a:defRPr sz="1950" b="1">
                 <a:solidFill>
                   <a:srgbClr val="0D766F"/>
@@ -15515,6 +15592,7 @@
               </a:defRPr>
             </a:lvl4pPr>
             <a:lvl5pPr>
+              <a:buNone/>
               <a:defRPr sz="1950" b="1">
                 <a:solidFill>
                   <a:srgbClr val="0D766F"/>
@@ -15522,6 +15600,7 @@
               </a:defRPr>
             </a:lvl5pPr>
             <a:lvl6pPr>
+              <a:buNone/>
               <a:defRPr sz="1950" b="1">
                 <a:solidFill>
                   <a:srgbClr val="0D766F"/>
@@ -15529,6 +15608,7 @@
               </a:defRPr>
             </a:lvl6pPr>
             <a:lvl7pPr>
+              <a:buNone/>
               <a:defRPr sz="1950" b="1">
                 <a:solidFill>
                   <a:srgbClr val="0D766F"/>
@@ -15536,6 +15616,7 @@
               </a:defRPr>
             </a:lvl7pPr>
             <a:lvl8pPr>
+              <a:buNone/>
               <a:defRPr sz="1950" b="1">
                 <a:solidFill>
                   <a:srgbClr val="0D766F"/>
@@ -15543,6 +15624,7 @@
               </a:defRPr>
             </a:lvl8pPr>
             <a:lvl9pPr>
+              <a:buNone/>
               <a:defRPr sz="1950" b="1">
                 <a:solidFill>
                   <a:srgbClr val="0D766F"/>
@@ -15552,6 +15634,7 @@
           </a:lstStyle>
           <a:p xmlns:a="http://schemas.openxmlformats.org/drawingml/2006/main">
             <a:pPr>
+              <a:buNone/>
               <a:defRPr sz="1950" b="1">
                 <a:solidFill>
                   <a:srgbClr val="0D766F"/>
@@ -15607,6 +15690,7 @@
               </a:defRPr>
             </a:defPPr>
             <a:lvl1pPr>
+              <a:buNone/>
               <a:defRPr sz="1800" b="0">
                 <a:solidFill>
                   <a:srgbClr val="192E50"/>
@@ -15614,6 +15698,7 @@
               </a:defRPr>
             </a:lvl1pPr>
             <a:lvl2pPr>
+              <a:buNone/>
               <a:defRPr sz="1800" b="0">
                 <a:solidFill>
                   <a:srgbClr val="192E50"/>
@@ -15621,6 +15706,7 @@
               </a:defRPr>
             </a:lvl2pPr>
             <a:lvl3pPr>
+              <a:buNone/>
               <a:defRPr sz="1800" b="0">
                 <a:solidFill>
                   <a:srgbClr val="192E50"/>
@@ -15628,6 +15714,7 @@
               </a:defRPr>
             </a:lvl3pPr>
             <a:lvl4pPr>
+              <a:buNone/>
               <a:defRPr sz="1800" b="0">
                 <a:solidFill>
                   <a:srgbClr val="192E50"/>
@@ -15635,6 +15722,7 @@
               </a:defRPr>
             </a:lvl4pPr>
             <a:lvl5pPr>
+              <a:buNone/>
               <a:defRPr sz="1800" b="0">
                 <a:solidFill>
                   <a:srgbClr val="192E50"/>
@@ -15642,6 +15730,7 @@
               </a:defRPr>
             </a:lvl5pPr>
             <a:lvl6pPr>
+              <a:buNone/>
               <a:defRPr sz="1800" b="0">
                 <a:solidFill>
                   <a:srgbClr val="192E50"/>
@@ -15649,6 +15738,7 @@
               </a:defRPr>
             </a:lvl6pPr>
             <a:lvl7pPr>
+              <a:buNone/>
               <a:defRPr sz="1800" b="0">
                 <a:solidFill>
                   <a:srgbClr val="192E50"/>
@@ -15656,6 +15746,7 @@
               </a:defRPr>
             </a:lvl7pPr>
             <a:lvl8pPr>
+              <a:buNone/>
               <a:defRPr sz="1800" b="0">
                 <a:solidFill>
                   <a:srgbClr val="192E50"/>
@@ -15663,6 +15754,7 @@
               </a:defRPr>
             </a:lvl8pPr>
             <a:lvl9pPr>
+              <a:buNone/>
               <a:defRPr sz="1800" b="0">
                 <a:solidFill>
                   <a:srgbClr val="192E50"/>
@@ -15672,6 +15764,7 @@
           </a:lstStyle>
           <a:p xmlns:a="http://schemas.openxmlformats.org/drawingml/2006/main">
             <a:pPr>
+              <a:buNone/>
               <a:defRPr sz="1800" b="0">
                 <a:solidFill>
                   <a:srgbClr val="192E50"/>
@@ -15694,6 +15787,7 @@
           </a:p>
           <a:p xmlns:a="http://schemas.openxmlformats.org/drawingml/2006/main">
             <a:pPr>
+              <a:buNone/>
               <a:defRPr sz="1800" b="0">
                 <a:solidFill>
                   <a:srgbClr val="192E50"/>
@@ -15716,6 +15810,7 @@
           </a:p>
           <a:p xmlns:a="http://schemas.openxmlformats.org/drawingml/2006/main">
             <a:pPr>
+              <a:buNone/>
               <a:defRPr sz="1800" b="0">
                 <a:solidFill>
                   <a:srgbClr val="192E50"/>
@@ -15771,6 +15866,7 @@
               </a:defRPr>
             </a:defPPr>
             <a:lvl1pPr>
+              <a:buNone/>
               <a:defRPr sz="1650" b="0">
                 <a:solidFill>
                   <a:srgbClr val="566B88"/>
@@ -15778,6 +15874,7 @@
               </a:defRPr>
             </a:lvl1pPr>
             <a:lvl2pPr>
+              <a:buNone/>
               <a:defRPr sz="1650" b="0">
                 <a:solidFill>
                   <a:srgbClr val="566B88"/>
@@ -15785,6 +15882,7 @@
               </a:defRPr>
             </a:lvl2pPr>
             <a:lvl3pPr>
+              <a:buNone/>
               <a:defRPr sz="1650" b="0">
                 <a:solidFill>
                   <a:srgbClr val="566B88"/>
@@ -15792,6 +15890,7 @@
               </a:defRPr>
             </a:lvl3pPr>
             <a:lvl4pPr>
+              <a:buNone/>
               <a:defRPr sz="1650" b="0">
                 <a:solidFill>
                   <a:srgbClr val="566B88"/>
@@ -15799,6 +15898,7 @@
               </a:defRPr>
             </a:lvl4pPr>
             <a:lvl5pPr>
+              <a:buNone/>
               <a:defRPr sz="1650" b="0">
                 <a:solidFill>
                   <a:srgbClr val="566B88"/>
@@ -15806,6 +15906,7 @@
               </a:defRPr>
             </a:lvl5pPr>
             <a:lvl6pPr>
+              <a:buNone/>
               <a:defRPr sz="1650" b="0">
                 <a:solidFill>
                   <a:srgbClr val="566B88"/>
@@ -15813,6 +15914,7 @@
               </a:defRPr>
             </a:lvl6pPr>
             <a:lvl7pPr>
+              <a:buNone/>
               <a:defRPr sz="1650" b="0">
                 <a:solidFill>
                   <a:srgbClr val="566B88"/>
@@ -15820,6 +15922,7 @@
               </a:defRPr>
             </a:lvl7pPr>
             <a:lvl8pPr>
+              <a:buNone/>
               <a:defRPr sz="1650" b="0">
                 <a:solidFill>
                   <a:srgbClr val="566B88"/>
@@ -15827,6 +15930,7 @@
               </a:defRPr>
             </a:lvl8pPr>
             <a:lvl9pPr>
+              <a:buNone/>
               <a:defRPr sz="1650" b="0">
                 <a:solidFill>
                   <a:srgbClr val="566B88"/>
@@ -15836,6 +15940,7 @@
           </a:lstStyle>
           <a:p xmlns:a="http://schemas.openxmlformats.org/drawingml/2006/main">
             <a:pPr>
+              <a:buNone/>
               <a:defRPr sz="1650" b="0">
                 <a:solidFill>
                   <a:srgbClr val="566B88"/>
@@ -15848,7 +15953,25 @@
                   <a:srgbClr val="566B88"/>
                 </a:solidFill>
               </a:rPr>
-              <a:t>기존 stdio MCP 클라이언트를 재사용합니다. 모니터링은 Tool, 런북 원문은 Resource입니다.</a:t>
+              <a:t>모니터링 Tool은 상태·CPU·메모리·알림을 제공합니다.</a:t>
+            </a:r>
+          </a:p>
+          <a:p xmlns:a="http://schemas.openxmlformats.org/drawingml/2006/main">
+            <a:pPr>
+              <a:buNone/>
+              <a:defRPr sz="1650" b="0">
+                <a:solidFill>
+                  <a:srgbClr val="566B88"/>
+                </a:solidFill>
+              </a:defRPr>
+            </a:pPr>
+            <a:r>
+              <a:rPr sz="1650" b="0">
+                <a:solidFill>
+                  <a:srgbClr val="566B88"/>
+                </a:solidFill>
+              </a:rPr>
+              <a:t>p95·커넥션 풀·시계열·로그는 별도 자료로 확인해야 합니다.</a:t>
             </a:r>
           </a:p>
         </p:txBody>
@@ -16644,6 +16767,7 @@
               </a:defRPr>
             </a:defPPr>
             <a:lvl1pPr>
+              <a:buNone/>
               <a:defRPr sz="1800" b="1">
                 <a:solidFill>
                   <a:srgbClr val="0D766F"/>
@@ -16651,6 +16775,7 @@
               </a:defRPr>
             </a:lvl1pPr>
             <a:lvl2pPr>
+              <a:buNone/>
               <a:defRPr sz="1800" b="1">
                 <a:solidFill>
                   <a:srgbClr val="0D766F"/>
@@ -16658,6 +16783,7 @@
               </a:defRPr>
             </a:lvl2pPr>
             <a:lvl3pPr>
+              <a:buNone/>
               <a:defRPr sz="1800" b="1">
                 <a:solidFill>
                   <a:srgbClr val="0D766F"/>
@@ -16665,6 +16791,7 @@
               </a:defRPr>
             </a:lvl3pPr>
             <a:lvl4pPr>
+              <a:buNone/>
               <a:defRPr sz="1800" b="1">
                 <a:solidFill>
                   <a:srgbClr val="0D766F"/>
@@ -16672,6 +16799,7 @@
               </a:defRPr>
             </a:lvl4pPr>
             <a:lvl5pPr>
+              <a:buNone/>
               <a:defRPr sz="1800" b="1">
                 <a:solidFill>
                   <a:srgbClr val="0D766F"/>
@@ -16679,6 +16807,7 @@
               </a:defRPr>
             </a:lvl5pPr>
             <a:lvl6pPr>
+              <a:buNone/>
               <a:defRPr sz="1800" b="1">
                 <a:solidFill>
                   <a:srgbClr val="0D766F"/>
@@ -16686,6 +16815,7 @@
               </a:defRPr>
             </a:lvl6pPr>
             <a:lvl7pPr>
+              <a:buNone/>
               <a:defRPr sz="1800" b="1">
                 <a:solidFill>
                   <a:srgbClr val="0D766F"/>
@@ -16693,6 +16823,7 @@
               </a:defRPr>
             </a:lvl7pPr>
             <a:lvl8pPr>
+              <a:buNone/>
               <a:defRPr sz="1800" b="1">
                 <a:solidFill>
                   <a:srgbClr val="0D766F"/>
@@ -16700,6 +16831,7 @@
               </a:defRPr>
             </a:lvl8pPr>
             <a:lvl9pPr>
+              <a:buNone/>
               <a:defRPr sz="1800" b="1">
                 <a:solidFill>
                   <a:srgbClr val="0D766F"/>
@@ -16709,6 +16841,7 @@
           </a:lstStyle>
           <a:p xmlns:a="http://schemas.openxmlformats.org/drawingml/2006/main">
             <a:pPr>
+              <a:buNone/>
               <a:defRPr sz="1800" b="1">
                 <a:solidFill>
                   <a:srgbClr val="0D766F"/>
@@ -16764,6 +16897,7 @@
               </a:defRPr>
             </a:defPPr>
             <a:lvl1pPr>
+              <a:buNone/>
               <a:defRPr sz="1500" b="0">
                 <a:solidFill>
                   <a:srgbClr val="192E50"/>
@@ -16771,6 +16905,7 @@
               </a:defRPr>
             </a:lvl1pPr>
             <a:lvl2pPr>
+              <a:buNone/>
               <a:defRPr sz="1500" b="0">
                 <a:solidFill>
                   <a:srgbClr val="192E50"/>
@@ -16778,6 +16913,7 @@
               </a:defRPr>
             </a:lvl2pPr>
             <a:lvl3pPr>
+              <a:buNone/>
               <a:defRPr sz="1500" b="0">
                 <a:solidFill>
                   <a:srgbClr val="192E50"/>
@@ -16785,6 +16921,7 @@
               </a:defRPr>
             </a:lvl3pPr>
             <a:lvl4pPr>
+              <a:buNone/>
               <a:defRPr sz="1500" b="0">
                 <a:solidFill>
                   <a:srgbClr val="192E50"/>
@@ -16792,6 +16929,7 @@
               </a:defRPr>
             </a:lvl4pPr>
             <a:lvl5pPr>
+              <a:buNone/>
               <a:defRPr sz="1500" b="0">
                 <a:solidFill>
                   <a:srgbClr val="192E50"/>
@@ -16799,6 +16937,7 @@
               </a:defRPr>
             </a:lvl5pPr>
             <a:lvl6pPr>
+              <a:buNone/>
               <a:defRPr sz="1500" b="0">
                 <a:solidFill>
                   <a:srgbClr val="192E50"/>
@@ -16806,6 +16945,7 @@
               </a:defRPr>
             </a:lvl6pPr>
             <a:lvl7pPr>
+              <a:buNone/>
               <a:defRPr sz="1500" b="0">
                 <a:solidFill>
                   <a:srgbClr val="192E50"/>
@@ -16813,6 +16953,7 @@
               </a:defRPr>
             </a:lvl7pPr>
             <a:lvl8pPr>
+              <a:buNone/>
               <a:defRPr sz="1500" b="0">
                 <a:solidFill>
                   <a:srgbClr val="192E50"/>
@@ -16820,6 +16961,7 @@
               </a:defRPr>
             </a:lvl8pPr>
             <a:lvl9pPr>
+              <a:buNone/>
               <a:defRPr sz="1500" b="0">
                 <a:solidFill>
                   <a:srgbClr val="192E50"/>
@@ -16829,6 +16971,7 @@
           </a:lstStyle>
           <a:p xmlns:a="http://schemas.openxmlformats.org/drawingml/2006/main">
             <a:pPr>
+              <a:buNone/>
               <a:defRPr sz="1500" b="0">
                 <a:solidFill>
                   <a:srgbClr val="192E50"/>
@@ -16846,6 +16989,7 @@
           </a:p>
           <a:p xmlns:a="http://schemas.openxmlformats.org/drawingml/2006/main">
             <a:pPr>
+              <a:buNone/>
               <a:defRPr sz="1500" b="0">
                 <a:solidFill>
                   <a:srgbClr val="192E50"/>
@@ -16863,6 +17007,7 @@
           </a:p>
           <a:p xmlns:a="http://schemas.openxmlformats.org/drawingml/2006/main">
             <a:pPr>
+              <a:buNone/>
               <a:defRPr sz="1500" b="0">
                 <a:solidFill>
                   <a:srgbClr val="192E50"/>
@@ -16880,6 +17025,7 @@
           </a:p>
           <a:p xmlns:a="http://schemas.openxmlformats.org/drawingml/2006/main">
             <a:pPr>
+              <a:buNone/>
               <a:defRPr sz="1500" b="0">
                 <a:solidFill>
                   <a:srgbClr val="192E50"/>
@@ -16897,6 +17043,7 @@
           </a:p>
           <a:p xmlns:a="http://schemas.openxmlformats.org/drawingml/2006/main">
             <a:pPr>
+              <a:buNone/>
               <a:defRPr sz="1500" b="0">
                 <a:solidFill>
                   <a:srgbClr val="192E50"/>
@@ -16914,6 +17061,7 @@
           </a:p>
           <a:p xmlns:a="http://schemas.openxmlformats.org/drawingml/2006/main">
             <a:pPr>
+              <a:buNone/>
               <a:defRPr sz="1500" b="0">
                 <a:solidFill>
                   <a:srgbClr val="192E50"/>
@@ -16931,6 +17079,7 @@
           </a:p>
           <a:p xmlns:a="http://schemas.openxmlformats.org/drawingml/2006/main">
             <a:pPr>
+              <a:buNone/>
               <a:defRPr sz="1500" b="0">
                 <a:solidFill>
                   <a:srgbClr val="192E50"/>
@@ -16986,6 +17135,7 @@
               </a:defRPr>
             </a:defPPr>
             <a:lvl1pPr>
+              <a:buNone/>
               <a:defRPr sz="1950" b="1">
                 <a:solidFill>
                   <a:srgbClr val="0D766F"/>
@@ -16993,6 +17143,7 @@
               </a:defRPr>
             </a:lvl1pPr>
             <a:lvl2pPr>
+              <a:buNone/>
               <a:defRPr sz="1950" b="1">
                 <a:solidFill>
                   <a:srgbClr val="0D766F"/>
@@ -17000,6 +17151,7 @@
               </a:defRPr>
             </a:lvl2pPr>
             <a:lvl3pPr>
+              <a:buNone/>
               <a:defRPr sz="1950" b="1">
                 <a:solidFill>
                   <a:srgbClr val="0D766F"/>
@@ -17007,6 +17159,7 @@
               </a:defRPr>
             </a:lvl3pPr>
             <a:lvl4pPr>
+              <a:buNone/>
               <a:defRPr sz="1950" b="1">
                 <a:solidFill>
                   <a:srgbClr val="0D766F"/>
@@ -17014,6 +17167,7 @@
               </a:defRPr>
             </a:lvl4pPr>
             <a:lvl5pPr>
+              <a:buNone/>
               <a:defRPr sz="1950" b="1">
                 <a:solidFill>
                   <a:srgbClr val="0D766F"/>
@@ -17021,6 +17175,7 @@
               </a:defRPr>
             </a:lvl5pPr>
             <a:lvl6pPr>
+              <a:buNone/>
               <a:defRPr sz="1950" b="1">
                 <a:solidFill>
                   <a:srgbClr val="0D766F"/>
@@ -17028,6 +17183,7 @@
               </a:defRPr>
             </a:lvl6pPr>
             <a:lvl7pPr>
+              <a:buNone/>
               <a:defRPr sz="1950" b="1">
                 <a:solidFill>
                   <a:srgbClr val="0D766F"/>
@@ -17035,6 +17191,7 @@
               </a:defRPr>
             </a:lvl7pPr>
             <a:lvl8pPr>
+              <a:buNone/>
               <a:defRPr sz="1950" b="1">
                 <a:solidFill>
                   <a:srgbClr val="0D766F"/>
@@ -17042,6 +17199,7 @@
               </a:defRPr>
             </a:lvl8pPr>
             <a:lvl9pPr>
+              <a:buNone/>
               <a:defRPr sz="1950" b="1">
                 <a:solidFill>
                   <a:srgbClr val="0D766F"/>
@@ -17051,6 +17209,7 @@
           </a:lstStyle>
           <a:p xmlns:a="http://schemas.openxmlformats.org/drawingml/2006/main">
             <a:pPr>
+              <a:buNone/>
               <a:defRPr sz="1950" b="1">
                 <a:solidFill>
                   <a:srgbClr val="0D766F"/>
@@ -17106,6 +17265,7 @@
               </a:defRPr>
             </a:defPPr>
             <a:lvl1pPr>
+              <a:buNone/>
               <a:defRPr sz="1800" b="0">
                 <a:solidFill>
                   <a:srgbClr val="192E50"/>
@@ -17113,6 +17273,7 @@
               </a:defRPr>
             </a:lvl1pPr>
             <a:lvl2pPr>
+              <a:buNone/>
               <a:defRPr sz="1800" b="0">
                 <a:solidFill>
                   <a:srgbClr val="192E50"/>
@@ -17120,6 +17281,7 @@
               </a:defRPr>
             </a:lvl2pPr>
             <a:lvl3pPr>
+              <a:buNone/>
               <a:defRPr sz="1800" b="0">
                 <a:solidFill>
                   <a:srgbClr val="192E50"/>
@@ -17127,6 +17289,7 @@
               </a:defRPr>
             </a:lvl3pPr>
             <a:lvl4pPr>
+              <a:buNone/>
               <a:defRPr sz="1800" b="0">
                 <a:solidFill>
                   <a:srgbClr val="192E50"/>
@@ -17134,6 +17297,7 @@
               </a:defRPr>
             </a:lvl4pPr>
             <a:lvl5pPr>
+              <a:buNone/>
               <a:defRPr sz="1800" b="0">
                 <a:solidFill>
                   <a:srgbClr val="192E50"/>
@@ -17141,6 +17305,7 @@
               </a:defRPr>
             </a:lvl5pPr>
             <a:lvl6pPr>
+              <a:buNone/>
               <a:defRPr sz="1800" b="0">
                 <a:solidFill>
                   <a:srgbClr val="192E50"/>
@@ -17148,6 +17313,7 @@
               </a:defRPr>
             </a:lvl6pPr>
             <a:lvl7pPr>
+              <a:buNone/>
               <a:defRPr sz="1800" b="0">
                 <a:solidFill>
                   <a:srgbClr val="192E50"/>
@@ -17155,6 +17321,7 @@
               </a:defRPr>
             </a:lvl7pPr>
             <a:lvl8pPr>
+              <a:buNone/>
               <a:defRPr sz="1800" b="0">
                 <a:solidFill>
                   <a:srgbClr val="192E50"/>
@@ -17162,6 +17329,7 @@
               </a:defRPr>
             </a:lvl8pPr>
             <a:lvl9pPr>
+              <a:buNone/>
               <a:defRPr sz="1800" b="0">
                 <a:solidFill>
                   <a:srgbClr val="192E50"/>
@@ -17171,6 +17339,7 @@
           </a:lstStyle>
           <a:p xmlns:a="http://schemas.openxmlformats.org/drawingml/2006/main">
             <a:pPr>
+              <a:buNone/>
               <a:defRPr sz="1800" b="0">
                 <a:solidFill>
                   <a:srgbClr val="192E50"/>
@@ -17193,6 +17362,7 @@
           </a:p>
           <a:p xmlns:a="http://schemas.openxmlformats.org/drawingml/2006/main">
             <a:pPr>
+              <a:buNone/>
               <a:defRPr sz="1800" b="0">
                 <a:solidFill>
                   <a:srgbClr val="192E50"/>
@@ -17215,6 +17385,7 @@
           </a:p>
           <a:p xmlns:a="http://schemas.openxmlformats.org/drawingml/2006/main">
             <a:pPr>
+              <a:buNone/>
               <a:defRPr sz="1800" b="0">
                 <a:solidFill>
                   <a:srgbClr val="192E50"/>
@@ -17270,6 +17441,7 @@
               </a:defRPr>
             </a:defPPr>
             <a:lvl1pPr>
+              <a:buNone/>
               <a:defRPr sz="1575" b="0">
                 <a:solidFill>
                   <a:srgbClr val="566B88"/>
@@ -17277,6 +17449,7 @@
               </a:defRPr>
             </a:lvl1pPr>
             <a:lvl2pPr>
+              <a:buNone/>
               <a:defRPr sz="1575" b="0">
                 <a:solidFill>
                   <a:srgbClr val="566B88"/>
@@ -17284,6 +17457,7 @@
               </a:defRPr>
             </a:lvl2pPr>
             <a:lvl3pPr>
+              <a:buNone/>
               <a:defRPr sz="1575" b="0">
                 <a:solidFill>
                   <a:srgbClr val="566B88"/>
@@ -17291,6 +17465,7 @@
               </a:defRPr>
             </a:lvl3pPr>
             <a:lvl4pPr>
+              <a:buNone/>
               <a:defRPr sz="1575" b="0">
                 <a:solidFill>
                   <a:srgbClr val="566B88"/>
@@ -17298,6 +17473,7 @@
               </a:defRPr>
             </a:lvl4pPr>
             <a:lvl5pPr>
+              <a:buNone/>
               <a:defRPr sz="1575" b="0">
                 <a:solidFill>
                   <a:srgbClr val="566B88"/>
@@ -17305,6 +17481,7 @@
               </a:defRPr>
             </a:lvl5pPr>
             <a:lvl6pPr>
+              <a:buNone/>
               <a:defRPr sz="1575" b="0">
                 <a:solidFill>
                   <a:srgbClr val="566B88"/>
@@ -17312,6 +17489,7 @@
               </a:defRPr>
             </a:lvl6pPr>
             <a:lvl7pPr>
+              <a:buNone/>
               <a:defRPr sz="1575" b="0">
                 <a:solidFill>
                   <a:srgbClr val="566B88"/>
@@ -17319,6 +17497,7 @@
               </a:defRPr>
             </a:lvl7pPr>
             <a:lvl8pPr>
+              <a:buNone/>
               <a:defRPr sz="1575" b="0">
                 <a:solidFill>
                   <a:srgbClr val="566B88"/>
@@ -17326,6 +17505,7 @@
               </a:defRPr>
             </a:lvl8pPr>
             <a:lvl9pPr>
+              <a:buNone/>
               <a:defRPr sz="1575" b="0">
                 <a:solidFill>
                   <a:srgbClr val="566B88"/>
@@ -17335,6 +17515,7 @@
           </a:lstStyle>
           <a:p xmlns:a="http://schemas.openxmlformats.org/drawingml/2006/main">
             <a:pPr>
+              <a:buNone/>
               <a:defRPr sz="1575" b="0">
                 <a:solidFill>
                   <a:srgbClr val="566B88"/>
@@ -21168,7 +21349,7 @@
                 <a:ea typeface="Apple SD Gothic Neo"/>
                 <a:cs typeface="Apple SD Gothic Neo"/>
               </a:rPr>
-              <a:t>시계열·배포 이력·호출 관계가 없습니다.</a:t>
+              <a:t>현재 p95·커넥션 풀·시계열·로그는 직접 조회하지 않습니다.</a:t>
             </a:r>
           </a:p>
           <a:p xmlns:a="http://schemas.openxmlformats.org/drawingml/2006/main">
@@ -21192,7 +21373,7 @@
                 <a:ea typeface="Apple SD Gothic Neo"/>
                 <a:cs typeface="Apple SD Gothic Neo"/>
               </a:rPr>
-              <a:t>근본 원인과 실제 복구를 확정할 수 없습니다.</a:t>
+              <a:t>근본 원인과 실제 복구는 미확인입니다.</a:t>
             </a:r>
           </a:p>
         </p:txBody>

</xml_diff>